<commit_message>
Add formal mathematical foundations compendium and high-res architecture diagram
</commit_message>
<xml_diff>
--- a/presentations/midterm_presentation/Midterm_PINNs_Presentation.pptx
+++ b/presentations/midterm_presentation/Midterm_PINNs_Presentation.pptx
@@ -14,6 +14,7 @@
     <p:sldId id="262" r:id="rId13"/>
     <p:sldId id="263" r:id="rId14"/>
     <p:sldId id="264" r:id="rId15"/>
+    <p:sldId id="265" r:id="rId16"/>
   </p:sldIdLst>
   <p:sldSz cx="12191695" cy="6858000" type="screen4x3"/>
   <p:notesSz cx="6858000" cy="9144000"/>
@@ -3301,6 +3302,134 @@
 </p:sld>
 </file>
 
+<file path=ppt/slides/slide10.xml><?xml version="1.0" encoding="utf-8"?>
+<p:sld xmlns:a="http://schemas.openxmlformats.org/drawingml/2006/main" xmlns:p="http://schemas.openxmlformats.org/presentationml/2006/main" xmlns:r="http://schemas.openxmlformats.org/officeDocument/2006/relationships">
+  <p:cSld>
+    <p:spTree>
+      <p:nvGrpSpPr>
+        <p:cNvPr id="1" name=""/>
+        <p:cNvGrpSpPr/>
+        <p:nvPr/>
+      </p:nvGrpSpPr>
+      <p:grpSpPr/>
+      <p:sp>
+        <p:nvSpPr>
+          <p:cNvPr id="2" name="Rectangle 1"/>
+          <p:cNvSpPr/>
+          <p:nvPr/>
+        </p:nvSpPr>
+        <p:spPr>
+          <a:xfrm>
+            <a:off x="0" y="0"/>
+            <a:ext cx="12191695" cy="6858000"/>
+          </a:xfrm>
+          <a:prstGeom prst="rect">
+            <a:avLst/>
+          </a:prstGeom>
+          <a:solidFill>
+            <a:srgbClr val="102C57"/>
+          </a:solidFill>
+          <a:ln>
+            <a:solidFill>
+              <a:srgbClr val="102C57"/>
+            </a:solidFill>
+          </a:ln>
+        </p:spPr>
+        <p:style>
+          <a:lnRef idx="1">
+            <a:schemeClr val="accent1"/>
+          </a:lnRef>
+          <a:fillRef idx="3">
+            <a:schemeClr val="accent1"/>
+          </a:fillRef>
+          <a:effectRef idx="2">
+            <a:schemeClr val="accent1"/>
+          </a:effectRef>
+          <a:fontRef idx="minor">
+            <a:schemeClr val="lt1"/>
+          </a:fontRef>
+        </p:style>
+        <p:txBody>
+          <a:bodyPr rtlCol="0" anchor="ctr"/>
+          <a:lstStyle/>
+          <a:p>
+            <a:pPr algn="ctr"/>
+          </a:p>
+        </p:txBody>
+      </p:sp>
+      <p:sp>
+        <p:nvSpPr>
+          <p:cNvPr id="3" name="TextBox 2"/>
+          <p:cNvSpPr txBox="1"/>
+          <p:nvPr/>
+        </p:nvSpPr>
+        <p:spPr>
+          <a:xfrm>
+            <a:off x="1371600" y="2011680"/>
+            <a:ext cx="9418320" cy="2743200"/>
+          </a:xfrm>
+          <a:prstGeom prst="rect">
+            <a:avLst/>
+          </a:prstGeom>
+          <a:noFill/>
+        </p:spPr>
+        <p:txBody>
+          <a:bodyPr wrap="none">
+            <a:spAutoFit/>
+          </a:bodyPr>
+          <a:lstStyle/>
+          <a:p>
+            <a:pPr algn="ctr">
+              <a:defRPr sz="4400" b="1">
+                <a:solidFill>
+                  <a:srgbClr val="D4A017"/>
+                </a:solidFill>
+              </a:defRPr>
+            </a:pPr>
+            <a:r>
+              <a:t>Thank You!</a:t>
+            </a:r>
+          </a:p>
+          <a:p>
+            <a:pPr algn="ctr">
+              <a:spcBef>
+                <a:spcPts val="2000"/>
+              </a:spcBef>
+              <a:defRPr sz="2200">
+                <a:solidFill>
+                  <a:srgbClr val="FFFFFF"/>
+                </a:solidFill>
+              </a:defRPr>
+            </a:pPr>
+            <a:r>
+              <a:t>Questions &amp; Suggestions are Warmly Welcomed.</a:t>
+            </a:r>
+          </a:p>
+          <a:p>
+            <a:pPr algn="ctr">
+              <a:spcBef>
+                <a:spcPts val="2500"/>
+              </a:spcBef>
+              <a:defRPr sz="1600">
+                <a:solidFill>
+                  <a:srgbClr val="B4C8DC"/>
+                </a:solidFill>
+              </a:defRPr>
+            </a:pPr>
+            <a:r>
+              <a:t>Candidate: Priyanshu Kumar | Department of Mathematics</a:t>
+            </a:r>
+          </a:p>
+        </p:txBody>
+      </p:sp>
+    </p:spTree>
+  </p:cSld>
+  <p:clrMapOvr>
+    <a:masterClrMapping/>
+  </p:clrMapOvr>
+</p:sld>
+</file>
+
 <file path=ppt/slides/slide2.xml><?xml version="1.0" encoding="utf-8"?>
 <p:sld xmlns:a="http://schemas.openxmlformats.org/drawingml/2006/main" xmlns:p="http://schemas.openxmlformats.org/presentationml/2006/main" xmlns:r="http://schemas.openxmlformats.org/officeDocument/2006/relationships">
   <p:cSld>
@@ -3655,7 +3784,7 @@
               </a:defRPr>
             </a:pPr>
             <a:r>
-              <a:t>• General PDE Operator: </a:t>
+              <a:t>• General PDE Operator in Hilbert Space: </a:t>
             </a:r>
             <a:r>
               <a:rPr b="0">
@@ -3663,7 +3792,7 @@
                   <a:srgbClr val="323232"/>
                 </a:solidFill>
               </a:rPr>
-              <a:t>Let D[u](x, t) = u_t + N_x[u] = 0 in domain Omega, with boundary conditions B(u, x, t) = 0 and initial state u(x, 0) = u_0(x).</a:t>
+              <a:t>Let D[u](x, t) = u_t + N_x[u] = 0 in domain Q_T, with boundary trace B[u] = 0 on Sigma_T and initial Cauchy data u(x, 0) = u_0(x).</a:t>
             </a:r>
           </a:p>
           <a:p>
@@ -3678,7 +3807,7 @@
               </a:defRPr>
             </a:pPr>
             <a:r>
-              <a:t>• Neural Network Approximation: </a:t>
+              <a:t>• Universal Derivative Approximation Theorem (Pinkus, 1999): </a:t>
             </a:r>
             <a:r>
               <a:rPr b="0">
@@ -3686,7 +3815,7 @@
                   <a:srgbClr val="323232"/>
                 </a:solidFill>
               </a:rPr>
-              <a:t>Approximate the unknown continuous solution u(x, t) using a deep neural network u_hat(x, t; theta) parameterized by weights and biases theta.</a:t>
+              <a:t>Smooth neural networks sigma in C^infinity (such as tanh or sin) can simultaneously approximate both the solution field u and its partial derivatives to arbitrary precision.</a:t>
             </a:r>
           </a:p>
           <a:p>
@@ -3701,7 +3830,7 @@
               </a:defRPr>
             </a:pPr>
             <a:r>
-              <a:t>• Automatic Differentiation (PyTorch Autograd): </a:t>
+              <a:t>• Reverse-Mode Automatic Differentiation (Autograd): </a:t>
             </a:r>
             <a:r>
               <a:rPr b="0">
@@ -3724,7 +3853,7 @@
               </a:defRPr>
             </a:pPr>
             <a:r>
-              <a:t>• Composite Multi-Objective Loss: </a:t>
+              <a:t>• Variational Loss Functional via Monte Carlo Quadrature: </a:t>
             </a:r>
             <a:r>
               <a:rPr b="0">
@@ -3732,7 +3861,7 @@
                   <a:srgbClr val="323232"/>
                 </a:solidFill>
               </a:rPr>
-              <a:t>Loss(theta) = w_data * MSE_data + w_pde * MSE_pde, where MSE_pde = (1/N_f) * sum |D[u_hat](x_f, t_f)|^2 computed at scattered interior collocation points.</a:t>
+              <a:t>L(theta) = lambda_data * MSE_data + lambda_pde * MSE_pde, where MSE_pde approximates the continuous L^2-norm integral ||D[u_hat]||^2 over scattered interior collocation points.</a:t>
             </a:r>
           </a:p>
         </p:txBody>
@@ -3746,6 +3875,137 @@
 </file>
 
 <file path=ppt/slides/slide4.xml><?xml version="1.0" encoding="utf-8"?>
+<p:sld xmlns:a="http://schemas.openxmlformats.org/drawingml/2006/main" xmlns:p="http://schemas.openxmlformats.org/presentationml/2006/main" xmlns:r="http://schemas.openxmlformats.org/officeDocument/2006/relationships">
+  <p:cSld>
+    <p:spTree>
+      <p:nvGrpSpPr>
+        <p:cNvPr id="1" name=""/>
+        <p:cNvGrpSpPr/>
+        <p:nvPr/>
+      </p:nvGrpSpPr>
+      <p:grpSpPr/>
+      <p:sp>
+        <p:nvSpPr>
+          <p:cNvPr id="2" name="Rectangle 1"/>
+          <p:cNvSpPr/>
+          <p:nvPr/>
+        </p:nvSpPr>
+        <p:spPr>
+          <a:xfrm>
+            <a:off x="0" y="0"/>
+            <a:ext cx="12191695" cy="1051560"/>
+          </a:xfrm>
+          <a:prstGeom prst="rect">
+            <a:avLst/>
+          </a:prstGeom>
+          <a:solidFill>
+            <a:srgbClr val="102C57"/>
+          </a:solidFill>
+          <a:ln>
+            <a:solidFill>
+              <a:srgbClr val="102C57"/>
+            </a:solidFill>
+          </a:ln>
+        </p:spPr>
+        <p:style>
+          <a:lnRef idx="1">
+            <a:schemeClr val="accent1"/>
+          </a:lnRef>
+          <a:fillRef idx="3">
+            <a:schemeClr val="accent1"/>
+          </a:fillRef>
+          <a:effectRef idx="2">
+            <a:schemeClr val="accent1"/>
+          </a:effectRef>
+          <a:fontRef idx="minor">
+            <a:schemeClr val="lt1"/>
+          </a:fontRef>
+        </p:style>
+        <p:txBody>
+          <a:bodyPr rtlCol="0" anchor="ctr" lIns="731520" tIns="320040"/>
+          <a:lstStyle/>
+          <a:p>
+            <a:pPr algn="l">
+              <a:defRPr sz="2200" b="1">
+                <a:solidFill>
+                  <a:srgbClr val="FFFFFF"/>
+                </a:solidFill>
+              </a:defRPr>
+            </a:pPr>
+            <a:r>
+              <a:t>3. Computational Graph &amp; Physics-Informed Workflow</a:t>
+            </a:r>
+          </a:p>
+        </p:txBody>
+      </p:sp>
+      <p:sp>
+        <p:nvSpPr>
+          <p:cNvPr id="3" name="TextBox 2"/>
+          <p:cNvSpPr txBox="1"/>
+          <p:nvPr/>
+        </p:nvSpPr>
+        <p:spPr>
+          <a:xfrm>
+            <a:off x="731520" y="109728"/>
+            <a:ext cx="10515600" cy="320040"/>
+          </a:xfrm>
+          <a:prstGeom prst="rect">
+            <a:avLst/>
+          </a:prstGeom>
+          <a:noFill/>
+        </p:spPr>
+        <p:txBody>
+          <a:bodyPr wrap="none">
+            <a:spAutoFit/>
+          </a:bodyPr>
+          <a:lstStyle/>
+          <a:p>
+            <a:pPr>
+              <a:defRPr sz="1100" b="1">
+                <a:solidFill>
+                  <a:srgbClr val="D4A017"/>
+                </a:solidFill>
+              </a:defRPr>
+            </a:pPr>
+            <a:r>
+              <a:t>MID-TERM DISSERTATION REVIEW</a:t>
+            </a:r>
+          </a:p>
+        </p:txBody>
+      </p:sp>
+      <p:pic>
+        <p:nvPicPr>
+          <p:cNvPr id="4" name="Picture 3" descr="pinn_mathematical_architecture.png"/>
+          <p:cNvPicPr>
+            <a:picLocks noChangeAspect="1"/>
+          </p:cNvPicPr>
+          <p:nvPr/>
+        </p:nvPicPr>
+        <p:blipFill>
+          <a:blip r:embed="rId2"/>
+          <a:stretch>
+            <a:fillRect/>
+          </a:stretch>
+        </p:blipFill>
+        <p:spPr>
+          <a:xfrm>
+            <a:off x="731520" y="1188720"/>
+            <a:ext cx="10725912" cy="6096022"/>
+          </a:xfrm>
+          <a:prstGeom prst="rect">
+            <a:avLst/>
+          </a:prstGeom>
+        </p:spPr>
+      </p:pic>
+    </p:spTree>
+  </p:cSld>
+  <p:clrMapOvr>
+    <a:masterClrMapping/>
+  </p:clrMapOvr>
+</p:sld>
+</file>
+
+<file path=ppt/slides/slide5.xml><?xml version="1.0" encoding="utf-8"?>
 <p:sld xmlns:a="http://schemas.openxmlformats.org/drawingml/2006/main" xmlns:p="http://schemas.openxmlformats.org/presentationml/2006/main" xmlns:r="http://schemas.openxmlformats.org/officeDocument/2006/relationships">
   <p:cSld>
     <p:spTree>
@@ -3915,7 +4175,7 @@
 </p:sld>
 </file>
 
-<file path=ppt/slides/slide5.xml><?xml version="1.0" encoding="utf-8"?>
+<file path=ppt/slides/slide6.xml><?xml version="1.0" encoding="utf-8"?>
 <p:sld xmlns:a="http://schemas.openxmlformats.org/drawingml/2006/main" xmlns:p="http://schemas.openxmlformats.org/presentationml/2006/main" xmlns:r="http://schemas.openxmlformats.org/officeDocument/2006/relationships">
   <p:cSld>
     <p:spTree>
@@ -4520,7 +4780,7 @@
 </p:sld>
 </file>
 
-<file path=ppt/slides/slide6.xml><?xml version="1.0" encoding="utf-8"?>
+<file path=ppt/slides/slide7.xml><?xml version="1.0" encoding="utf-8"?>
 <p:sld xmlns:a="http://schemas.openxmlformats.org/drawingml/2006/main" xmlns:p="http://schemas.openxmlformats.org/presentationml/2006/main" xmlns:r="http://schemas.openxmlformats.org/officeDocument/2006/relationships">
   <p:cSld>
     <p:spTree>
@@ -4690,7 +4950,7 @@
 </p:sld>
 </file>
 
-<file path=ppt/slides/slide7.xml><?xml version="1.0" encoding="utf-8"?>
+<file path=ppt/slides/slide8.xml><?xml version="1.0" encoding="utf-8"?>
 <p:sld xmlns:a="http://schemas.openxmlformats.org/drawingml/2006/main" xmlns:p="http://schemas.openxmlformats.org/presentationml/2006/main" xmlns:r="http://schemas.openxmlformats.org/officeDocument/2006/relationships">
   <p:cSld>
     <p:spTree>
@@ -4912,7 +5172,7 @@
 </p:sld>
 </file>
 
-<file path=ppt/slides/slide8.xml><?xml version="1.0" encoding="utf-8"?>
+<file path=ppt/slides/slide9.xml><?xml version="1.0" encoding="utf-8"?>
 <p:sld xmlns:a="http://schemas.openxmlformats.org/drawingml/2006/main" xmlns:p="http://schemas.openxmlformats.org/presentationml/2006/main" xmlns:r="http://schemas.openxmlformats.org/officeDocument/2006/relationships">
   <p:cSld>
     <p:spTree>
@@ -5122,134 +5382,6 @@
                 </a:solidFill>
               </a:rPr>
               <a:t>Complete LaTeX dissertation report, generate publication-grade figures, and prepare the final viva presentation.</a:t>
-            </a:r>
-          </a:p>
-        </p:txBody>
-      </p:sp>
-    </p:spTree>
-  </p:cSld>
-  <p:clrMapOvr>
-    <a:masterClrMapping/>
-  </p:clrMapOvr>
-</p:sld>
-</file>
-
-<file path=ppt/slides/slide9.xml><?xml version="1.0" encoding="utf-8"?>
-<p:sld xmlns:a="http://schemas.openxmlformats.org/drawingml/2006/main" xmlns:p="http://schemas.openxmlformats.org/presentationml/2006/main" xmlns:r="http://schemas.openxmlformats.org/officeDocument/2006/relationships">
-  <p:cSld>
-    <p:spTree>
-      <p:nvGrpSpPr>
-        <p:cNvPr id="1" name=""/>
-        <p:cNvGrpSpPr/>
-        <p:nvPr/>
-      </p:nvGrpSpPr>
-      <p:grpSpPr/>
-      <p:sp>
-        <p:nvSpPr>
-          <p:cNvPr id="2" name="Rectangle 1"/>
-          <p:cNvSpPr/>
-          <p:nvPr/>
-        </p:nvSpPr>
-        <p:spPr>
-          <a:xfrm>
-            <a:off x="0" y="0"/>
-            <a:ext cx="12191695" cy="6858000"/>
-          </a:xfrm>
-          <a:prstGeom prst="rect">
-            <a:avLst/>
-          </a:prstGeom>
-          <a:solidFill>
-            <a:srgbClr val="102C57"/>
-          </a:solidFill>
-          <a:ln>
-            <a:solidFill>
-              <a:srgbClr val="102C57"/>
-            </a:solidFill>
-          </a:ln>
-        </p:spPr>
-        <p:style>
-          <a:lnRef idx="1">
-            <a:schemeClr val="accent1"/>
-          </a:lnRef>
-          <a:fillRef idx="3">
-            <a:schemeClr val="accent1"/>
-          </a:fillRef>
-          <a:effectRef idx="2">
-            <a:schemeClr val="accent1"/>
-          </a:effectRef>
-          <a:fontRef idx="minor">
-            <a:schemeClr val="lt1"/>
-          </a:fontRef>
-        </p:style>
-        <p:txBody>
-          <a:bodyPr rtlCol="0" anchor="ctr"/>
-          <a:lstStyle/>
-          <a:p>
-            <a:pPr algn="ctr"/>
-          </a:p>
-        </p:txBody>
-      </p:sp>
-      <p:sp>
-        <p:nvSpPr>
-          <p:cNvPr id="3" name="TextBox 2"/>
-          <p:cNvSpPr txBox="1"/>
-          <p:nvPr/>
-        </p:nvSpPr>
-        <p:spPr>
-          <a:xfrm>
-            <a:off x="1371600" y="2011680"/>
-            <a:ext cx="9418320" cy="2743200"/>
-          </a:xfrm>
-          <a:prstGeom prst="rect">
-            <a:avLst/>
-          </a:prstGeom>
-          <a:noFill/>
-        </p:spPr>
-        <p:txBody>
-          <a:bodyPr wrap="none">
-            <a:spAutoFit/>
-          </a:bodyPr>
-          <a:lstStyle/>
-          <a:p>
-            <a:pPr algn="ctr">
-              <a:defRPr sz="4400" b="1">
-                <a:solidFill>
-                  <a:srgbClr val="D4A017"/>
-                </a:solidFill>
-              </a:defRPr>
-            </a:pPr>
-            <a:r>
-              <a:t>Thank You!</a:t>
-            </a:r>
-          </a:p>
-          <a:p>
-            <a:pPr algn="ctr">
-              <a:spcBef>
-                <a:spcPts val="2000"/>
-              </a:spcBef>
-              <a:defRPr sz="2200">
-                <a:solidFill>
-                  <a:srgbClr val="FFFFFF"/>
-                </a:solidFill>
-              </a:defRPr>
-            </a:pPr>
-            <a:r>
-              <a:t>Questions &amp; Suggestions are Warmly Welcomed.</a:t>
-            </a:r>
-          </a:p>
-          <a:p>
-            <a:pPr algn="ctr">
-              <a:spcBef>
-                <a:spcPts val="2500"/>
-              </a:spcBef>
-              <a:defRPr sz="1600">
-                <a:solidFill>
-                  <a:srgbClr val="B4C8DC"/>
-                </a:solidFill>
-              </a:defRPr>
-            </a:pPr>
-            <a:r>
-              <a:t>Candidate: Priyanshu Kumar | Department of Mathematics</a:t>
             </a:r>
           </a:p>
         </p:txBody>

</xml_diff>